<commit_message>
Deck AIB: testimonio del Lcdo. Ernest Crison (chat + voz + CRM)
</commit_message>
<xml_diff>
--- a/demos/ai-borinquen-deck/ai-borinquen.pptx
+++ b/demos/ai-borinquen-deck/ai-borinquen.pptx
@@ -2295,19 +2295,136 @@
             </a:avLst>
           </a:prstGeom>
           <a:solidFill>
-            <a:srgbClr val="07160F"/>
+            <a:srgbClr val="0D2118"/>
           </a:solidFill>
           <a:ln w="12700">
             <a:solidFill>
               <a:srgbClr val="1F3A2B"/>
             </a:solidFill>
-            <a:prstDash val="dash"/>
+            <a:prstDash val="solid"/>
           </a:ln>
         </p:spPr>
       </p:sp>
       <p:sp>
         <p:nvSpPr>
-          <p:cNvPr id="16" name="Shape 13"/>
+          <p:cNvPr id="16" name="Text 13"/>
+          <p:cNvSpPr/>
+          <p:nvPr/>
+        </p:nvSpPr>
+        <p:spPr>
+          <a:xfrm>
+            <a:off x="822960" y="3218688"/>
+            <a:ext cx="3474720" cy="320040"/>
+          </a:xfrm>
+          <a:prstGeom prst="rect">
+            <a:avLst/>
+          </a:prstGeom>
+          <a:noFill/>
+          <a:ln/>
+        </p:spPr>
+        <p:txBody>
+          <a:bodyPr wrap="square" rtlCol="0" anchor="ctr"/>
+          <a:lstStyle/>
+          <a:p>
+            <a:pPr indent="0" marL="0">
+              <a:buNone/>
+            </a:pPr>
+            <a:r>
+              <a:rPr lang="en-US" sz="1300" b="1" dirty="0">
+                <a:solidFill>
+                  <a:srgbClr val="E9F5EE"/>
+                </a:solidFill>
+                <a:latin typeface="Helvetica" pitchFamily="34" charset="0"/>
+                <a:ea typeface="Helvetica" pitchFamily="34" charset="-122"/>
+                <a:cs typeface="Helvetica" pitchFamily="34" charset="-120"/>
+              </a:rPr>
+              <a:t>Lcdo. Ernest Crison</a:t>
+            </a:r>
+            <a:endParaRPr lang="en-US" sz="1300" dirty="0"/>
+          </a:p>
+        </p:txBody>
+      </p:sp>
+      <p:sp>
+        <p:nvSpPr>
+          <p:cNvPr id="17" name="Text 14"/>
+          <p:cNvSpPr/>
+          <p:nvPr/>
+        </p:nvSpPr>
+        <p:spPr>
+          <a:xfrm>
+            <a:off x="822960" y="3493008"/>
+            <a:ext cx="3474720" cy="228600"/>
+          </a:xfrm>
+          <a:prstGeom prst="rect">
+            <a:avLst/>
+          </a:prstGeom>
+          <a:noFill/>
+          <a:ln/>
+        </p:spPr>
+        <p:txBody>
+          <a:bodyPr wrap="square" rtlCol="0" anchor="ctr"/>
+          <a:lstStyle/>
+          <a:p>
+            <a:pPr indent="0" marL="0">
+              <a:buNone/>
+            </a:pPr>
+            <a:r>
+              <a:rPr lang="en-US" sz="900" spc="200" kern="0" dirty="0">
+                <a:solidFill>
+                  <a:srgbClr val="35C06F"/>
+                </a:solidFill>
+                <a:latin typeface="Helvetica" pitchFamily="34" charset="0"/>
+                <a:ea typeface="Helvetica" pitchFamily="34" charset="-122"/>
+                <a:cs typeface="Helvetica" pitchFamily="34" charset="-120"/>
+              </a:rPr>
+              <a:t>Oficina legal</a:t>
+            </a:r>
+            <a:endParaRPr lang="en-US" sz="900" dirty="0"/>
+          </a:p>
+        </p:txBody>
+      </p:sp>
+      <p:sp>
+        <p:nvSpPr>
+          <p:cNvPr id="18" name="Text 15"/>
+          <p:cNvSpPr/>
+          <p:nvPr/>
+        </p:nvSpPr>
+        <p:spPr>
+          <a:xfrm>
+            <a:off x="822960" y="3730752"/>
+            <a:ext cx="3474720" cy="621792"/>
+          </a:xfrm>
+          <a:prstGeom prst="rect">
+            <a:avLst/>
+          </a:prstGeom>
+          <a:noFill/>
+          <a:ln/>
+        </p:spPr>
+        <p:txBody>
+          <a:bodyPr wrap="square" rtlCol="0" anchor="t"/>
+          <a:lstStyle/>
+          <a:p>
+            <a:pPr indent="0" marL="0">
+              <a:buNone/>
+            </a:pPr>
+            <a:r>
+              <a:rPr lang="en-US" sz="1100" dirty="0">
+                <a:solidFill>
+                  <a:srgbClr val="9DB8AA"/>
+                </a:solidFill>
+                <a:latin typeface="Helvetica" pitchFamily="34" charset="0"/>
+                <a:ea typeface="Helvetica" pitchFamily="34" charset="-122"/>
+                <a:cs typeface="Helvetica" pitchFamily="34" charset="-120"/>
+              </a:rPr>
+              <a:t>Ecosistema completo: agente de chat, agente de voz y CRM. Ningún cliente se queda sin respuesta.</a:t>
+            </a:r>
+            <a:endParaRPr lang="en-US" sz="1100" dirty="0"/>
+          </a:p>
+        </p:txBody>
+      </p:sp>
+      <p:sp>
+        <p:nvSpPr>
+          <p:cNvPr id="19" name="Shape 16"/>
           <p:cNvSpPr/>
           <p:nvPr/>
         </p:nvSpPr>

</xml_diff>

<commit_message>
Testimonio real del Lcdo. Ernest Crison (video transcrito con Cortex) en el deck de AIB y en el vault
</commit_message>
<xml_diff>
--- a/demos/ai-borinquen-deck/ai-borinquen.pptx
+++ b/demos/ai-borinquen-deck/ai-borinquen.pptx
@@ -2377,7 +2377,7 @@
                 <a:ea typeface="Helvetica" pitchFamily="34" charset="-122"/>
                 <a:cs typeface="Helvetica" pitchFamily="34" charset="-120"/>
               </a:rPr>
-              <a:t>Oficina legal</a:t>
+              <a:t>Oficina legal · chat + voz + CRM</a:t>
             </a:r>
             <a:endParaRPr lang="en-US" sz="900" dirty="0"/>
           </a:p>
@@ -2408,7 +2408,7 @@
               <a:buNone/>
             </a:pPr>
             <a:r>
-              <a:rPr lang="en-US" sz="1100" dirty="0">
+              <a:rPr lang="en-US" sz="1100" i="1" dirty="0">
                 <a:solidFill>
                   <a:srgbClr val="9DB8AA"/>
                 </a:solidFill>
@@ -2416,7 +2416,7 @@
                 <a:ea typeface="Helvetica" pitchFamily="34" charset="-122"/>
                 <a:cs typeface="Helvetica" pitchFamily="34" charset="-120"/>
               </a:rPr>
-              <a:t>Ecosistema completo: agente de chat, agente de voz y CRM. Ningún cliente se queda sin respuesta.</a:t>
+              <a:t>“Llenaron mis expectativas y las superaron. No doy abasto en llamadas y citas. Entran 25 a 50 mensajes al día, casi siempre de madrugada… gracias a Dios que está el sistema.”</a:t>
             </a:r>
             <a:endParaRPr lang="en-US" sz="1100" dirty="0"/>
           </a:p>

</xml_diff>

<commit_message>
Deck AIB: ángulo de agentes personalizados (no solo leads sin responder)
</commit_message>
<xml_diff>
--- a/demos/ai-borinquen-deck/ai-borinquen.pptx
+++ b/demos/ai-borinquen-deck/ai-borinquen.pptx
@@ -1182,8 +1182,8 @@
         </p:nvSpPr>
         <p:spPr>
           <a:xfrm>
-            <a:off x="640080" y="1188720"/>
-            <a:ext cx="7863840" cy="1463040"/>
+            <a:off x="640080" y="960120"/>
+            <a:ext cx="7863840" cy="1737360"/>
           </a:xfrm>
           <a:prstGeom prst="rect">
             <a:avLst/>
@@ -1199,7 +1199,7 @@
               <a:buNone/>
             </a:pPr>
             <a:r>
-              <a:rPr lang="en-US" sz="3400" b="1" dirty="0">
+              <a:rPr lang="en-US" sz="3000" b="1" dirty="0">
                 <a:solidFill>
                   <a:srgbClr val="E9F5EE"/>
                 </a:solidFill>
@@ -1207,16 +1207,16 @@
                 <a:ea typeface="Helvetica" pitchFamily="34" charset="-122"/>
                 <a:cs typeface="Helvetica" pitchFamily="34" charset="-120"/>
               </a:rPr>
-              <a:t>Agentes de inteligencia artificial</a:t>
-            </a:r>
-            <a:endParaRPr lang="en-US" sz="3400" dirty="0"/>
-          </a:p>
-          <a:p>
-            <a:pPr indent="0" marL="0">
-              <a:buNone/>
-            </a:pPr>
-            <a:r>
-              <a:rPr lang="en-US" sz="3400" b="1" dirty="0">
+              <a:t>Agentes de IA personalizados</a:t>
+            </a:r>
+            <a:endParaRPr lang="en-US" sz="3000" dirty="0"/>
+          </a:p>
+          <a:p>
+            <a:pPr indent="0" marL="0">
+              <a:buNone/>
+            </a:pPr>
+            <a:r>
+              <a:rPr lang="en-US" sz="3000" b="1" dirty="0">
                 <a:solidFill>
                   <a:srgbClr val="E9F5EE"/>
                 </a:solidFill>
@@ -1224,9 +1224,26 @@
                 <a:ea typeface="Helvetica" pitchFamily="34" charset="-122"/>
                 <a:cs typeface="Helvetica" pitchFamily="34" charset="-120"/>
               </a:rPr>
-              <a:t>hechos en Puerto Rico.</a:t>
-            </a:r>
-            <a:endParaRPr lang="en-US" sz="3400" dirty="0"/>
+              <a:t>para tu negocio.</a:t>
+            </a:r>
+            <a:endParaRPr lang="en-US" sz="3000" dirty="0"/>
+          </a:p>
+          <a:p>
+            <a:pPr indent="0" marL="0">
+              <a:buNone/>
+            </a:pPr>
+            <a:r>
+              <a:rPr lang="en-US" sz="3000" b="1" dirty="0">
+                <a:solidFill>
+                  <a:srgbClr val="E9F5EE"/>
+                </a:solidFill>
+                <a:latin typeface="Helvetica" pitchFamily="34" charset="0"/>
+                <a:ea typeface="Helvetica" pitchFamily="34" charset="-122"/>
+                <a:cs typeface="Helvetica" pitchFamily="34" charset="-120"/>
+              </a:rPr>
+              <a:t>Hechos en Puerto Rico.</a:t>
+            </a:r>
+            <a:endParaRPr lang="en-US" sz="3000" dirty="0"/>
           </a:p>
         </p:txBody>
       </p:sp>
@@ -1238,8 +1255,8 @@
         </p:nvSpPr>
         <p:spPr>
           <a:xfrm>
-            <a:off x="640080" y="2880360"/>
-            <a:ext cx="7498080" cy="1005840"/>
+            <a:off x="640080" y="2743200"/>
+            <a:ext cx="7863840" cy="914400"/>
           </a:xfrm>
           <a:prstGeom prst="rect">
             <a:avLst/>
@@ -1255,7 +1272,7 @@
               <a:buNone/>
             </a:pPr>
             <a:r>
-              <a:rPr lang="en-US" sz="1600" dirty="0">
+              <a:rPr lang="en-US" sz="1500" dirty="0">
                 <a:solidFill>
                   <a:srgbClr val="9DB8AA"/>
                 </a:solidFill>
@@ -1263,16 +1280,16 @@
                 <a:ea typeface="Helvetica" pitchFamily="34" charset="-122"/>
                 <a:cs typeface="Helvetica" pitchFamily="34" charset="-120"/>
               </a:rPr>
-              <a:t>Instalamos el empleado digital que contesta, precalifica y agenda por tu negocio.</a:t>
-            </a:r>
-            <a:endParaRPr lang="en-US" sz="1600" dirty="0"/>
-          </a:p>
-          <a:p>
-            <a:pPr indent="0" marL="0">
-              <a:buNone/>
-            </a:pPr>
-            <a:r>
-              <a:rPr lang="en-US" sz="1600" dirty="0">
+              <a:t>Diseñamos, entrenamos e instalamos el agente que tu negocio necesita:</a:t>
+            </a:r>
+            <a:endParaRPr lang="en-US" sz="1500" dirty="0"/>
+          </a:p>
+          <a:p>
+            <a:pPr indent="0" marL="0">
+              <a:buNone/>
+            </a:pPr>
+            <a:r>
+              <a:rPr lang="en-US" sz="1500" dirty="0">
                 <a:solidFill>
                   <a:srgbClr val="9DB8AA"/>
                 </a:solidFill>
@@ -1280,9 +1297,243 @@
                 <a:ea typeface="Helvetica" pitchFamily="34" charset="-122"/>
                 <a:cs typeface="Helvetica" pitchFamily="34" charset="-120"/>
               </a:rPr>
-              <a:t>No un chatbot.</a:t>
-            </a:r>
-            <a:endParaRPr lang="en-US" sz="1600" dirty="0"/>
+              <a:t>recepción, ventas, WhatsApp, citas, seguimiento, inventario, cobros… el que te haga falta.</a:t>
+            </a:r>
+            <a:endParaRPr lang="en-US" sz="1500" dirty="0"/>
+          </a:p>
+        </p:txBody>
+      </p:sp>
+      <p:sp>
+        <p:nvSpPr>
+          <p:cNvPr id="8" name="Text 5"/>
+          <p:cNvSpPr/>
+          <p:nvPr/>
+        </p:nvSpPr>
+        <p:spPr>
+          <a:xfrm>
+            <a:off x="640080" y="3749040"/>
+            <a:ext cx="2560320" cy="320040"/>
+          </a:xfrm>
+          <a:prstGeom prst="rect">
+            <a:avLst/>
+          </a:prstGeom>
+          <a:noFill/>
+          <a:ln/>
+        </p:spPr>
+        <p:txBody>
+          <a:bodyPr wrap="square" rtlCol="0" anchor="ctr"/>
+          <a:lstStyle/>
+          <a:p>
+            <a:pPr indent="0" marL="0">
+              <a:buNone/>
+            </a:pPr>
+            <a:r>
+              <a:rPr lang="en-US" sz="1200" dirty="0">
+                <a:solidFill>
+                  <a:srgbClr val="E9F5EE"/>
+                </a:solidFill>
+                <a:latin typeface="Helvetica" pitchFamily="34" charset="0"/>
+                <a:ea typeface="Helvetica" pitchFamily="34" charset="-122"/>
+                <a:cs typeface="Helvetica" pitchFamily="34" charset="-120"/>
+              </a:rPr>
+              <a:t>· Recepción y citas</a:t>
+            </a:r>
+            <a:endParaRPr lang="en-US" sz="1200" dirty="0"/>
+          </a:p>
+        </p:txBody>
+      </p:sp>
+      <p:sp>
+        <p:nvSpPr>
+          <p:cNvPr id="9" name="Text 6"/>
+          <p:cNvSpPr/>
+          <p:nvPr/>
+        </p:nvSpPr>
+        <p:spPr>
+          <a:xfrm>
+            <a:off x="3337560" y="3749040"/>
+            <a:ext cx="2560320" cy="320040"/>
+          </a:xfrm>
+          <a:prstGeom prst="rect">
+            <a:avLst/>
+          </a:prstGeom>
+          <a:noFill/>
+          <a:ln/>
+        </p:spPr>
+        <p:txBody>
+          <a:bodyPr wrap="square" rtlCol="0" anchor="ctr"/>
+          <a:lstStyle/>
+          <a:p>
+            <a:pPr indent="0" marL="0">
+              <a:buNone/>
+            </a:pPr>
+            <a:r>
+              <a:rPr lang="en-US" sz="1200" dirty="0">
+                <a:solidFill>
+                  <a:srgbClr val="E9F5EE"/>
+                </a:solidFill>
+                <a:latin typeface="Helvetica" pitchFamily="34" charset="0"/>
+                <a:ea typeface="Helvetica" pitchFamily="34" charset="-122"/>
+                <a:cs typeface="Helvetica" pitchFamily="34" charset="-120"/>
+              </a:rPr>
+              <a:t>· Ventas por WhatsApp</a:t>
+            </a:r>
+            <a:endParaRPr lang="en-US" sz="1200" dirty="0"/>
+          </a:p>
+        </p:txBody>
+      </p:sp>
+      <p:sp>
+        <p:nvSpPr>
+          <p:cNvPr id="10" name="Text 7"/>
+          <p:cNvSpPr/>
+          <p:nvPr/>
+        </p:nvSpPr>
+        <p:spPr>
+          <a:xfrm>
+            <a:off x="6035040" y="3749040"/>
+            <a:ext cx="2560320" cy="320040"/>
+          </a:xfrm>
+          <a:prstGeom prst="rect">
+            <a:avLst/>
+          </a:prstGeom>
+          <a:noFill/>
+          <a:ln/>
+        </p:spPr>
+        <p:txBody>
+          <a:bodyPr wrap="square" rtlCol="0" anchor="ctr"/>
+          <a:lstStyle/>
+          <a:p>
+            <a:pPr indent="0" marL="0">
+              <a:buNone/>
+            </a:pPr>
+            <a:r>
+              <a:rPr lang="en-US" sz="1200" dirty="0">
+                <a:solidFill>
+                  <a:srgbClr val="E9F5EE"/>
+                </a:solidFill>
+                <a:latin typeface="Helvetica" pitchFamily="34" charset="0"/>
+                <a:ea typeface="Helvetica" pitchFamily="34" charset="-122"/>
+                <a:cs typeface="Helvetica" pitchFamily="34" charset="-120"/>
+              </a:rPr>
+              <a:t>· Seguimiento de clientes</a:t>
+            </a:r>
+            <a:endParaRPr lang="en-US" sz="1200" dirty="0"/>
+          </a:p>
+        </p:txBody>
+      </p:sp>
+      <p:sp>
+        <p:nvSpPr>
+          <p:cNvPr id="11" name="Text 8"/>
+          <p:cNvSpPr/>
+          <p:nvPr/>
+        </p:nvSpPr>
+        <p:spPr>
+          <a:xfrm>
+            <a:off x="640080" y="4133088"/>
+            <a:ext cx="2560320" cy="320040"/>
+          </a:xfrm>
+          <a:prstGeom prst="rect">
+            <a:avLst/>
+          </a:prstGeom>
+          <a:noFill/>
+          <a:ln/>
+        </p:spPr>
+        <p:txBody>
+          <a:bodyPr wrap="square" rtlCol="0" anchor="ctr"/>
+          <a:lstStyle/>
+          <a:p>
+            <a:pPr indent="0" marL="0">
+              <a:buNone/>
+            </a:pPr>
+            <a:r>
+              <a:rPr lang="en-US" sz="1200" dirty="0">
+                <a:solidFill>
+                  <a:srgbClr val="E9F5EE"/>
+                </a:solidFill>
+                <a:latin typeface="Helvetica" pitchFamily="34" charset="0"/>
+                <a:ea typeface="Helvetica" pitchFamily="34" charset="-122"/>
+                <a:cs typeface="Helvetica" pitchFamily="34" charset="-120"/>
+              </a:rPr>
+              <a:t>· Inventario y pedidos</a:t>
+            </a:r>
+            <a:endParaRPr lang="en-US" sz="1200" dirty="0"/>
+          </a:p>
+        </p:txBody>
+      </p:sp>
+      <p:sp>
+        <p:nvSpPr>
+          <p:cNvPr id="12" name="Text 9"/>
+          <p:cNvSpPr/>
+          <p:nvPr/>
+        </p:nvSpPr>
+        <p:spPr>
+          <a:xfrm>
+            <a:off x="3337560" y="4133088"/>
+            <a:ext cx="2560320" cy="320040"/>
+          </a:xfrm>
+          <a:prstGeom prst="rect">
+            <a:avLst/>
+          </a:prstGeom>
+          <a:noFill/>
+          <a:ln/>
+        </p:spPr>
+        <p:txBody>
+          <a:bodyPr wrap="square" rtlCol="0" anchor="ctr"/>
+          <a:lstStyle/>
+          <a:p>
+            <a:pPr indent="0" marL="0">
+              <a:buNone/>
+            </a:pPr>
+            <a:r>
+              <a:rPr lang="en-US" sz="1200" dirty="0">
+                <a:solidFill>
+                  <a:srgbClr val="E9F5EE"/>
+                </a:solidFill>
+                <a:latin typeface="Helvetica" pitchFamily="34" charset="0"/>
+                <a:ea typeface="Helvetica" pitchFamily="34" charset="-122"/>
+                <a:cs typeface="Helvetica" pitchFamily="34" charset="-120"/>
+              </a:rPr>
+              <a:t>· Cobros y recordatorios</a:t>
+            </a:r>
+            <a:endParaRPr lang="en-US" sz="1200" dirty="0"/>
+          </a:p>
+        </p:txBody>
+      </p:sp>
+      <p:sp>
+        <p:nvSpPr>
+          <p:cNvPr id="13" name="Text 10"/>
+          <p:cNvSpPr/>
+          <p:nvPr/>
+        </p:nvSpPr>
+        <p:spPr>
+          <a:xfrm>
+            <a:off x="6035040" y="4133088"/>
+            <a:ext cx="2560320" cy="320040"/>
+          </a:xfrm>
+          <a:prstGeom prst="rect">
+            <a:avLst/>
+          </a:prstGeom>
+          <a:noFill/>
+          <a:ln/>
+        </p:spPr>
+        <p:txBody>
+          <a:bodyPr wrap="square" rtlCol="0" anchor="ctr"/>
+          <a:lstStyle/>
+          <a:p>
+            <a:pPr indent="0" marL="0">
+              <a:buNone/>
+            </a:pPr>
+            <a:r>
+              <a:rPr lang="en-US" sz="1200" b="1" dirty="0">
+                <a:solidFill>
+                  <a:srgbClr val="35C06F"/>
+                </a:solidFill>
+                <a:latin typeface="Helvetica" pitchFamily="34" charset="0"/>
+                <a:ea typeface="Helvetica" pitchFamily="34" charset="-122"/>
+                <a:cs typeface="Helvetica" pitchFamily="34" charset="-120"/>
+              </a:rPr>
+              <a:t>· El tuyo</a:t>
+            </a:r>
+            <a:endParaRPr lang="en-US" sz="1200" dirty="0"/>
           </a:p>
         </p:txBody>
       </p:sp>
@@ -1472,7 +1723,7 @@
                 <a:ea typeface="Helvetica" pitchFamily="34" charset="-122"/>
                 <a:cs typeface="Helvetica" pitchFamily="34" charset="-120"/>
               </a:rPr>
-              <a:t>Que ningún negocio de la isla</a:t>
+              <a:t>Que cada negocio de la isla</a:t>
             </a:r>
             <a:endParaRPr lang="en-US" sz="3000" dirty="0"/>
           </a:p>
@@ -1489,7 +1740,7 @@
                 <a:ea typeface="Helvetica" pitchFamily="34" charset="-122"/>
                 <a:cs typeface="Helvetica" pitchFamily="34" charset="-120"/>
               </a:rPr>
-              <a:t>pierda un cliente por no contestar a tiempo.</a:t>
+              <a:t>tenga su propio equipo de IA.</a:t>
             </a:r>
             <a:endParaRPr lang="en-US" sz="3000" dirty="0"/>
           </a:p>
@@ -1551,7 +1802,7 @@
                 <a:ea typeface="Helvetica" pitchFamily="34" charset="-122"/>
                 <a:cs typeface="Helvetica" pitchFamily="34" charset="-120"/>
               </a:rPr>
-              <a:t>Digitalizar</a:t>
+              <a:t>Personalizar</a:t>
             </a:r>
             <a:endParaRPr lang="en-US" sz="1500" dirty="0"/>
           </a:p>
@@ -1590,7 +1841,7 @@
                 <a:ea typeface="Helvetica" pitchFamily="34" charset="-122"/>
                 <a:cs typeface="Helvetica" pitchFamily="34" charset="-120"/>
               </a:rPr>
-              <a:t>Lo instalamos por ti.</a:t>
+              <a:t>Agentes a la medida de tu operación, no plantillas.</a:t>
             </a:r>
             <a:endParaRPr lang="en-US" sz="1200" dirty="0"/>
           </a:p>
@@ -1652,7 +1903,7 @@
                 <a:ea typeface="Helvetica" pitchFamily="34" charset="-122"/>
                 <a:cs typeface="Helvetica" pitchFamily="34" charset="-120"/>
               </a:rPr>
-              <a:t>Capacitar</a:t>
+              <a:t>Digitalizar y capacitar</a:t>
             </a:r>
             <a:endParaRPr lang="en-US" sz="1500" dirty="0"/>
           </a:p>
@@ -1691,7 +1942,7 @@
                 <a:ea typeface="Helvetica" pitchFamily="34" charset="-122"/>
                 <a:cs typeface="Helvetica" pitchFamily="34" charset="-120"/>
               </a:rPr>
-              <a:t>O te enseñamos a hacerlo tú.</a:t>
+              <a:t>Lo instalamos por ti, o te enseñamos a hacerlo tú.</a:t>
             </a:r>
             <a:endParaRPr lang="en-US" sz="1200" dirty="0"/>
           </a:p>
@@ -1792,7 +2043,7 @@
                 <a:ea typeface="Helvetica" pitchFamily="34" charset="-122"/>
                 <a:cs typeface="Helvetica" pitchFamily="34" charset="-120"/>
               </a:rPr>
-              <a:t>Tú ves cada llamada y cada lead.</a:t>
+              <a:t>Tú ves lo que tu agente hace, cada día.</a:t>
             </a:r>
             <a:endParaRPr lang="en-US" sz="1200" dirty="0"/>
           </a:p>

</xml_diff>

<commit_message>
Deck AIB: slide 4 con espacios para testimonios en video
</commit_message>
<xml_diff>
--- a/demos/ai-borinquen-deck/ai-borinquen.pptx
+++ b/demos/ai-borinquen-deck/ai-borinquen.pptx
@@ -8,9 +8,10 @@
     <p:sldId id="256" r:id="rId2"/>
     <p:sldId id="257" r:id="rId3"/>
     <p:sldId id="258" r:id="rId4"/>
+    <p:sldId id="259" r:id="rId5"/>
   </p:sldIdLst>
   <p:notesMasterIdLst>
-    <p:notesMasterId r:id="rId5"/>
+    <p:notesMasterId r:id="rId6"/>
   </p:notesMasterIdLst>
   <p:sldSz cx="9144000" cy="5143500"/>
   <p:notesSz cx="5143500" cy="9144000"/>
@@ -704,6 +705,94 @@
             <a:fld id="{F7021451-1387-4CA6-816F-3879F97B5CBC}" type="slidenum">
               <a:rPr lang="en-US"/>
               <a:t>3</a:t>
+            </a:fld>
+            <a:endParaRPr lang="en-US"/>
+          </a:p>
+        </p:txBody>
+      </p:sp>
+    </p:spTree>
+    <p:extLst>
+      <p:ext uri="{BB962C8B-B14F-4D97-AF65-F5344CB8AC3E}">
+        <p14:creationId xmlns:p14="http://schemas.microsoft.com/office/powerpoint/2010/main" val="1024086991"/>
+      </p:ext>
+    </p:extLst>
+  </p:cSld>
+  <p:clrMapOvr>
+    <a:masterClrMapping/>
+  </p:clrMapOvr>
+</p:notes>
+</file>
+
+<file path=ppt/notesSlides/notesSlide4.xml><?xml version="1.0" encoding="utf-8"?>
+<p:notes xmlns:a="http://schemas.openxmlformats.org/drawingml/2006/main" xmlns:r="http://schemas.openxmlformats.org/officeDocument/2006/relationships" xmlns:p="http://schemas.openxmlformats.org/presentationml/2006/main">
+  <p:cSld>
+    <p:spTree>
+      <p:nvGrpSpPr>
+        <p:cNvPr id="1" name=""/>
+        <p:cNvGrpSpPr/>
+        <p:nvPr/>
+      </p:nvGrpSpPr>
+      <p:grpSpPr>
+        <a:xfrm>
+          <a:off x="0" y="0"/>
+          <a:ext cx="0" cy="0"/>
+          <a:chOff x="0" y="0"/>
+          <a:chExt cx="0" cy="0"/>
+        </a:xfrm>
+      </p:grpSpPr>
+      <p:sp>
+        <p:nvSpPr>
+          <p:cNvPr id="2" name="Slide Image Placeholder 1"/>
+          <p:cNvSpPr>
+            <a:spLocks noGrp="1" noRot="1" noChangeAspect="1"/>
+          </p:cNvSpPr>
+          <p:nvPr>
+            <p:ph type="sldImg"/>
+          </p:nvPr>
+        </p:nvSpPr>
+        <p:spPr/>
+      </p:sp>
+      <p:sp>
+        <p:nvSpPr>
+          <p:cNvPr id="3" name="Notes Placeholder 2"/>
+          <p:cNvSpPr>
+            <a:spLocks noGrp="1"/>
+          </p:cNvSpPr>
+          <p:nvPr>
+            <p:ph type="body" idx="1"/>
+          </p:nvPr>
+        </p:nvSpPr>
+        <p:spPr/>
+        <p:txBody>
+          <a:bodyPr/>
+          <a:lstStyle/>
+          <a:p>
+            <a:r>
+              <a:rPr lang="en-US" dirty="0"/>
+              <a:t/>
+            </a:r>
+            <a:endParaRPr lang="en-US" dirty="0"/>
+          </a:p>
+        </p:txBody>
+      </p:sp>
+      <p:sp>
+        <p:nvSpPr>
+          <p:cNvPr id="4" name="Slide Number Placeholder 3"/>
+          <p:cNvSpPr>
+            <a:spLocks noGrp="1"/>
+          </p:cNvSpPr>
+          <p:nvPr>
+            <p:ph type="sldNum" sz="quarter" idx="10"/>
+          </p:nvPr>
+        </p:nvSpPr>
+        <p:spPr/>
+        <p:txBody>
+          <a:bodyPr/>
+          <a:lstStyle/>
+          <a:p>
+            <a:fld id="{F7021451-1387-4CA6-816F-3879F97B5CBC}" type="slidenum">
+              <a:rPr lang="en-US"/>
+              <a:t>4</a:t>
             </a:fld>
             <a:endParaRPr lang="en-US"/>
           </a:p>
@@ -2708,6 +2797,679 @@
 </p:sld>
 </file>
 
+<file path=ppt/slides/slide4.xml><?xml version="1.0" encoding="utf-8"?>
+<p:sld xmlns:a="http://schemas.openxmlformats.org/drawingml/2006/main" xmlns:r="http://schemas.openxmlformats.org/officeDocument/2006/relationships" xmlns:p="http://schemas.openxmlformats.org/presentationml/2006/main">
+  <p:cSld name="Slide 4">
+    <p:bg>
+      <p:bgPr>
+        <a:solidFill>
+          <a:srgbClr val="07160F"/>
+        </a:solidFill>
+      </p:bgPr>
+    </p:bg>
+    <p:spTree>
+      <p:nvGrpSpPr>
+        <p:cNvPr id="1" name=""/>
+        <p:cNvGrpSpPr/>
+        <p:nvPr/>
+      </p:nvGrpSpPr>
+      <p:grpSpPr>
+        <a:xfrm>
+          <a:off x="0" y="0"/>
+          <a:ext cx="0" cy="0"/>
+          <a:chOff x="0" y="0"/>
+          <a:chExt cx="0" cy="0"/>
+        </a:xfrm>
+      </p:grpSpPr>
+      <p:sp>
+        <p:nvSpPr>
+          <p:cNvPr id="2" name="Shape 0"/>
+          <p:cNvSpPr/>
+          <p:nvPr/>
+        </p:nvSpPr>
+        <p:spPr>
+          <a:xfrm>
+            <a:off x="0" y="0"/>
+            <a:ext cx="164592" cy="5143500"/>
+          </a:xfrm>
+          <a:prstGeom prst="rect">
+            <a:avLst/>
+          </a:prstGeom>
+          <a:solidFill>
+            <a:srgbClr val="35C06F"/>
+          </a:solidFill>
+          <a:ln/>
+        </p:spPr>
+      </p:sp>
+      <p:sp>
+        <p:nvSpPr>
+          <p:cNvPr id="3" name="Text 1"/>
+          <p:cNvSpPr/>
+          <p:nvPr/>
+        </p:nvSpPr>
+        <p:spPr>
+          <a:xfrm>
+            <a:off x="640080" y="411480"/>
+            <a:ext cx="7315200" cy="274320"/>
+          </a:xfrm>
+          <a:prstGeom prst="rect">
+            <a:avLst/>
+          </a:prstGeom>
+          <a:noFill/>
+          <a:ln/>
+        </p:spPr>
+        <p:txBody>
+          <a:bodyPr wrap="square" rtlCol="0" anchor="ctr"/>
+          <a:lstStyle/>
+          <a:p>
+            <a:pPr indent="0" marL="0">
+              <a:buNone/>
+            </a:pPr>
+            <a:r>
+              <a:rPr lang="en-US" sz="1000" b="1" spc="400" kern="0" dirty="0">
+                <a:solidFill>
+                  <a:srgbClr val="35C06F"/>
+                </a:solidFill>
+                <a:latin typeface="Helvetica" pitchFamily="34" charset="0"/>
+                <a:ea typeface="Helvetica" pitchFamily="34" charset="-122"/>
+                <a:cs typeface="Helvetica" pitchFamily="34" charset="-120"/>
+              </a:rPr>
+              <a:t>LO DICEN ELLOS</a:t>
+            </a:r>
+            <a:endParaRPr lang="en-US" sz="1000" dirty="0"/>
+          </a:p>
+        </p:txBody>
+      </p:sp>
+      <p:pic>
+        <p:nvPicPr>
+          <p:cNvPr id="4" name="Image 0" descr="/Users/elvinayala/AGENTE CONTENIDO/public/marcas/ai-borinquen-logo-dark.png">    </p:cNvPr>
+          <p:cNvPicPr>
+            <a:picLocks noChangeAspect="1"/>
+          </p:cNvPicPr>
+          <p:nvPr/>
+        </p:nvPicPr>
+        <p:blipFill>
+          <a:blip r:embed="rId1"/>
+          <a:srcRect l="0" r="0" t="0" b="0"/>
+          <a:stretch/>
+        </p:blipFill>
+        <p:spPr>
+          <a:xfrm>
+            <a:off x="7818120" y="320040"/>
+            <a:ext cx="914400" cy="457200"/>
+          </a:xfrm>
+          <a:prstGeom prst="rect">
+            <a:avLst/>
+          </a:prstGeom>
+        </p:spPr>
+      </p:pic>
+      <p:sp>
+        <p:nvSpPr>
+          <p:cNvPr id="5" name="Text 2"/>
+          <p:cNvSpPr/>
+          <p:nvPr/>
+        </p:nvSpPr>
+        <p:spPr>
+          <a:xfrm>
+            <a:off x="640080" y="4709160"/>
+            <a:ext cx="5486400" cy="274320"/>
+          </a:xfrm>
+          <a:prstGeom prst="rect">
+            <a:avLst/>
+          </a:prstGeom>
+          <a:noFill/>
+          <a:ln/>
+        </p:spPr>
+        <p:txBody>
+          <a:bodyPr wrap="square" rtlCol="0" anchor="ctr"/>
+          <a:lstStyle/>
+          <a:p>
+            <a:pPr indent="0" marL="0">
+              <a:buNone/>
+            </a:pPr>
+            <a:r>
+              <a:rPr lang="en-US" sz="900" dirty="0">
+                <a:solidFill>
+                  <a:srgbClr val="9DB8AA"/>
+                </a:solidFill>
+                <a:latin typeface="Helvetica" pitchFamily="34" charset="0"/>
+                <a:ea typeface="Helvetica" pitchFamily="34" charset="-122"/>
+                <a:cs typeface="Helvetica" pitchFamily="34" charset="-120"/>
+              </a:rPr>
+              <a:t>AI Borinquen · Puerto Rico</a:t>
+            </a:r>
+            <a:endParaRPr lang="en-US" sz="900" dirty="0"/>
+          </a:p>
+        </p:txBody>
+      </p:sp>
+      <p:sp>
+        <p:nvSpPr>
+          <p:cNvPr id="6" name="Text 3"/>
+          <p:cNvSpPr/>
+          <p:nvPr/>
+        </p:nvSpPr>
+        <p:spPr>
+          <a:xfrm>
+            <a:off x="640080" y="914400"/>
+            <a:ext cx="7315200" cy="548640"/>
+          </a:xfrm>
+          <a:prstGeom prst="rect">
+            <a:avLst/>
+          </a:prstGeom>
+          <a:noFill/>
+          <a:ln/>
+        </p:spPr>
+        <p:txBody>
+          <a:bodyPr wrap="square" rtlCol="0" anchor="ctr"/>
+          <a:lstStyle/>
+          <a:p>
+            <a:pPr indent="0" marL="0">
+              <a:buNone/>
+            </a:pPr>
+            <a:r>
+              <a:rPr lang="en-US" sz="2800" b="1" dirty="0">
+                <a:solidFill>
+                  <a:srgbClr val="E9F5EE"/>
+                </a:solidFill>
+                <a:latin typeface="Helvetica" pitchFamily="34" charset="0"/>
+                <a:ea typeface="Helvetica" pitchFamily="34" charset="-122"/>
+                <a:cs typeface="Helvetica" pitchFamily="34" charset="-120"/>
+              </a:rPr>
+              <a:t>Testimonios en video.</a:t>
+            </a:r>
+            <a:endParaRPr lang="en-US" sz="2800" dirty="0"/>
+          </a:p>
+        </p:txBody>
+      </p:sp>
+      <p:sp>
+        <p:nvSpPr>
+          <p:cNvPr id="7" name="Shape 4"/>
+          <p:cNvSpPr/>
+          <p:nvPr/>
+        </p:nvSpPr>
+        <p:spPr>
+          <a:xfrm>
+            <a:off x="640080" y="1600200"/>
+            <a:ext cx="1783080" cy="2788920"/>
+          </a:xfrm>
+          <a:prstGeom prst="roundRect">
+            <a:avLst>
+              <a:gd name="adj" fmla="val 5128"/>
+            </a:avLst>
+          </a:prstGeom>
+          <a:solidFill>
+            <a:srgbClr val="0D2118"/>
+          </a:solidFill>
+          <a:ln w="12700">
+            <a:solidFill>
+              <a:srgbClr val="1F3A2B"/>
+            </a:solidFill>
+            <a:prstDash val="dash"/>
+          </a:ln>
+        </p:spPr>
+      </p:sp>
+      <p:sp>
+        <p:nvSpPr>
+          <p:cNvPr id="8" name="Shape 5"/>
+          <p:cNvSpPr/>
+          <p:nvPr/>
+        </p:nvSpPr>
+        <p:spPr>
+          <a:xfrm>
+            <a:off x="1257300" y="2720340"/>
+            <a:ext cx="548640" cy="548640"/>
+          </a:xfrm>
+          <a:prstGeom prst="ellipse">
+            <a:avLst/>
+          </a:prstGeom>
+          <a:solidFill>
+            <a:srgbClr val="07160F"/>
+          </a:solidFill>
+          <a:ln w="19050">
+            <a:solidFill>
+              <a:srgbClr val="35C06F"/>
+            </a:solidFill>
+            <a:prstDash val="solid"/>
+          </a:ln>
+        </p:spPr>
+      </p:sp>
+      <p:sp>
+        <p:nvSpPr>
+          <p:cNvPr id="9" name="Text 6"/>
+          <p:cNvSpPr/>
+          <p:nvPr/>
+        </p:nvSpPr>
+        <p:spPr>
+          <a:xfrm>
+            <a:off x="1257300" y="2720340"/>
+            <a:ext cx="548640" cy="548640"/>
+          </a:xfrm>
+          <a:prstGeom prst="rect">
+            <a:avLst/>
+          </a:prstGeom>
+          <a:noFill/>
+          <a:ln/>
+        </p:spPr>
+        <p:txBody>
+          <a:bodyPr wrap="square" rtlCol="0" anchor="ctr"/>
+          <a:lstStyle/>
+          <a:p>
+            <a:pPr algn="ctr" indent="0" marL="0">
+              <a:buNone/>
+            </a:pPr>
+            <a:r>
+              <a:rPr lang="en-US" sz="1600" dirty="0">
+                <a:solidFill>
+                  <a:srgbClr val="35C06F"/>
+                </a:solidFill>
+                <a:latin typeface="Helvetica" pitchFamily="34" charset="0"/>
+                <a:ea typeface="Helvetica" pitchFamily="34" charset="-122"/>
+                <a:cs typeface="Helvetica" pitchFamily="34" charset="-120"/>
+              </a:rPr>
+              <a:t>▶</a:t>
+            </a:r>
+            <a:endParaRPr lang="en-US" sz="1600" dirty="0"/>
+          </a:p>
+        </p:txBody>
+      </p:sp>
+      <p:sp>
+        <p:nvSpPr>
+          <p:cNvPr id="10" name="Text 7"/>
+          <p:cNvSpPr/>
+          <p:nvPr/>
+        </p:nvSpPr>
+        <p:spPr>
+          <a:xfrm>
+            <a:off x="640080" y="4434840"/>
+            <a:ext cx="1783080" cy="274320"/>
+          </a:xfrm>
+          <a:prstGeom prst="rect">
+            <a:avLst/>
+          </a:prstGeom>
+          <a:noFill/>
+          <a:ln/>
+        </p:spPr>
+        <p:txBody>
+          <a:bodyPr wrap="square" rtlCol="0" anchor="ctr"/>
+          <a:lstStyle/>
+          <a:p>
+            <a:pPr algn="ctr" indent="0" marL="0">
+              <a:buNone/>
+            </a:pPr>
+            <a:r>
+              <a:rPr lang="en-US" sz="1000" dirty="0">
+                <a:solidFill>
+                  <a:srgbClr val="9DB8AA"/>
+                </a:solidFill>
+                <a:latin typeface="Helvetica" pitchFamily="34" charset="0"/>
+                <a:ea typeface="Helvetica" pitchFamily="34" charset="-122"/>
+                <a:cs typeface="Helvetica" pitchFamily="34" charset="-120"/>
+              </a:rPr>
+              <a:t>Lcdo. Ernest Crison</a:t>
+            </a:r>
+            <a:endParaRPr lang="en-US" sz="1000" dirty="0"/>
+          </a:p>
+        </p:txBody>
+      </p:sp>
+      <p:sp>
+        <p:nvSpPr>
+          <p:cNvPr id="11" name="Shape 8"/>
+          <p:cNvSpPr/>
+          <p:nvPr/>
+        </p:nvSpPr>
+        <p:spPr>
+          <a:xfrm>
+            <a:off x="2651760" y="1600200"/>
+            <a:ext cx="1783080" cy="2788920"/>
+          </a:xfrm>
+          <a:prstGeom prst="roundRect">
+            <a:avLst>
+              <a:gd name="adj" fmla="val 5128"/>
+            </a:avLst>
+          </a:prstGeom>
+          <a:solidFill>
+            <a:srgbClr val="0D2118"/>
+          </a:solidFill>
+          <a:ln w="12700">
+            <a:solidFill>
+              <a:srgbClr val="1F3A2B"/>
+            </a:solidFill>
+            <a:prstDash val="dash"/>
+          </a:ln>
+        </p:spPr>
+      </p:sp>
+      <p:sp>
+        <p:nvSpPr>
+          <p:cNvPr id="12" name="Shape 9"/>
+          <p:cNvSpPr/>
+          <p:nvPr/>
+        </p:nvSpPr>
+        <p:spPr>
+          <a:xfrm>
+            <a:off x="3268980" y="2720340"/>
+            <a:ext cx="548640" cy="548640"/>
+          </a:xfrm>
+          <a:prstGeom prst="ellipse">
+            <a:avLst/>
+          </a:prstGeom>
+          <a:solidFill>
+            <a:srgbClr val="07160F"/>
+          </a:solidFill>
+          <a:ln w="19050">
+            <a:solidFill>
+              <a:srgbClr val="35C06F"/>
+            </a:solidFill>
+            <a:prstDash val="solid"/>
+          </a:ln>
+        </p:spPr>
+      </p:sp>
+      <p:sp>
+        <p:nvSpPr>
+          <p:cNvPr id="13" name="Text 10"/>
+          <p:cNvSpPr/>
+          <p:nvPr/>
+        </p:nvSpPr>
+        <p:spPr>
+          <a:xfrm>
+            <a:off x="3268980" y="2720340"/>
+            <a:ext cx="548640" cy="548640"/>
+          </a:xfrm>
+          <a:prstGeom prst="rect">
+            <a:avLst/>
+          </a:prstGeom>
+          <a:noFill/>
+          <a:ln/>
+        </p:spPr>
+        <p:txBody>
+          <a:bodyPr wrap="square" rtlCol="0" anchor="ctr"/>
+          <a:lstStyle/>
+          <a:p>
+            <a:pPr algn="ctr" indent="0" marL="0">
+              <a:buNone/>
+            </a:pPr>
+            <a:r>
+              <a:rPr lang="en-US" sz="1600" dirty="0">
+                <a:solidFill>
+                  <a:srgbClr val="35C06F"/>
+                </a:solidFill>
+                <a:latin typeface="Helvetica" pitchFamily="34" charset="0"/>
+                <a:ea typeface="Helvetica" pitchFamily="34" charset="-122"/>
+                <a:cs typeface="Helvetica" pitchFamily="34" charset="-120"/>
+              </a:rPr>
+              <a:t>▶</a:t>
+            </a:r>
+            <a:endParaRPr lang="en-US" sz="1600" dirty="0"/>
+          </a:p>
+        </p:txBody>
+      </p:sp>
+      <p:sp>
+        <p:nvSpPr>
+          <p:cNvPr id="14" name="Text 11"/>
+          <p:cNvSpPr/>
+          <p:nvPr/>
+        </p:nvSpPr>
+        <p:spPr>
+          <a:xfrm>
+            <a:off x="2651760" y="4434840"/>
+            <a:ext cx="1783080" cy="274320"/>
+          </a:xfrm>
+          <a:prstGeom prst="rect">
+            <a:avLst/>
+          </a:prstGeom>
+          <a:noFill/>
+          <a:ln/>
+        </p:spPr>
+        <p:txBody>
+          <a:bodyPr wrap="square" rtlCol="0" anchor="ctr"/>
+          <a:lstStyle/>
+          <a:p>
+            <a:pPr algn="ctr" indent="0" marL="0">
+              <a:buNone/>
+            </a:pPr>
+            <a:r>
+              <a:rPr lang="en-US" sz="1000" dirty="0">
+                <a:solidFill>
+                  <a:srgbClr val="9DB8AA"/>
+                </a:solidFill>
+                <a:latin typeface="Helvetica" pitchFamily="34" charset="0"/>
+                <a:ea typeface="Helvetica" pitchFamily="34" charset="-122"/>
+                <a:cs typeface="Helvetica" pitchFamily="34" charset="-120"/>
+              </a:rPr>
+              <a:t>Teo · Mano Santa PR</a:t>
+            </a:r>
+            <a:endParaRPr lang="en-US" sz="1000" dirty="0"/>
+          </a:p>
+        </p:txBody>
+      </p:sp>
+      <p:sp>
+        <p:nvSpPr>
+          <p:cNvPr id="15" name="Shape 12"/>
+          <p:cNvSpPr/>
+          <p:nvPr/>
+        </p:nvSpPr>
+        <p:spPr>
+          <a:xfrm>
+            <a:off x="4663440" y="1600200"/>
+            <a:ext cx="1783080" cy="2788920"/>
+          </a:xfrm>
+          <a:prstGeom prst="roundRect">
+            <a:avLst>
+              <a:gd name="adj" fmla="val 5128"/>
+            </a:avLst>
+          </a:prstGeom>
+          <a:solidFill>
+            <a:srgbClr val="0D2118"/>
+          </a:solidFill>
+          <a:ln w="12700">
+            <a:solidFill>
+              <a:srgbClr val="1F3A2B"/>
+            </a:solidFill>
+            <a:prstDash val="dash"/>
+          </a:ln>
+        </p:spPr>
+      </p:sp>
+      <p:sp>
+        <p:nvSpPr>
+          <p:cNvPr id="16" name="Shape 13"/>
+          <p:cNvSpPr/>
+          <p:nvPr/>
+        </p:nvSpPr>
+        <p:spPr>
+          <a:xfrm>
+            <a:off x="5280660" y="2720340"/>
+            <a:ext cx="548640" cy="548640"/>
+          </a:xfrm>
+          <a:prstGeom prst="ellipse">
+            <a:avLst/>
+          </a:prstGeom>
+          <a:solidFill>
+            <a:srgbClr val="07160F"/>
+          </a:solidFill>
+          <a:ln w="19050">
+            <a:solidFill>
+              <a:srgbClr val="35C06F"/>
+            </a:solidFill>
+            <a:prstDash val="solid"/>
+          </a:ln>
+        </p:spPr>
+      </p:sp>
+      <p:sp>
+        <p:nvSpPr>
+          <p:cNvPr id="17" name="Text 14"/>
+          <p:cNvSpPr/>
+          <p:nvPr/>
+        </p:nvSpPr>
+        <p:spPr>
+          <a:xfrm>
+            <a:off x="5280660" y="2720340"/>
+            <a:ext cx="548640" cy="548640"/>
+          </a:xfrm>
+          <a:prstGeom prst="rect">
+            <a:avLst/>
+          </a:prstGeom>
+          <a:noFill/>
+          <a:ln/>
+        </p:spPr>
+        <p:txBody>
+          <a:bodyPr wrap="square" rtlCol="0" anchor="ctr"/>
+          <a:lstStyle/>
+          <a:p>
+            <a:pPr algn="ctr" indent="0" marL="0">
+              <a:buNone/>
+            </a:pPr>
+            <a:r>
+              <a:rPr lang="en-US" sz="1600" dirty="0">
+                <a:solidFill>
+                  <a:srgbClr val="35C06F"/>
+                </a:solidFill>
+                <a:latin typeface="Helvetica" pitchFamily="34" charset="0"/>
+                <a:ea typeface="Helvetica" pitchFamily="34" charset="-122"/>
+                <a:cs typeface="Helvetica" pitchFamily="34" charset="-120"/>
+              </a:rPr>
+              <a:t>▶</a:t>
+            </a:r>
+            <a:endParaRPr lang="en-US" sz="1600" dirty="0"/>
+          </a:p>
+        </p:txBody>
+      </p:sp>
+      <p:sp>
+        <p:nvSpPr>
+          <p:cNvPr id="18" name="Text 15"/>
+          <p:cNvSpPr/>
+          <p:nvPr/>
+        </p:nvSpPr>
+        <p:spPr>
+          <a:xfrm>
+            <a:off x="4663440" y="4434840"/>
+            <a:ext cx="1783080" cy="274320"/>
+          </a:xfrm>
+          <a:prstGeom prst="rect">
+            <a:avLst/>
+          </a:prstGeom>
+          <a:noFill/>
+          <a:ln/>
+        </p:spPr>
+        <p:txBody>
+          <a:bodyPr wrap="square" rtlCol="0" anchor="ctr"/>
+          <a:lstStyle/>
+          <a:p>
+            <a:pPr algn="ctr" indent="0" marL="0">
+              <a:buNone/>
+            </a:pPr>
+            <a:r>
+              <a:rPr lang="en-US" sz="1000" dirty="0">
+                <a:solidFill>
+                  <a:srgbClr val="9DB8AA"/>
+                </a:solidFill>
+                <a:latin typeface="Helvetica" pitchFamily="34" charset="0"/>
+                <a:ea typeface="Helvetica" pitchFamily="34" charset="-122"/>
+                <a:cs typeface="Helvetica" pitchFamily="34" charset="-120"/>
+              </a:rPr>
+              <a:t>Milton · Caribe Paint</a:t>
+            </a:r>
+            <a:endParaRPr lang="en-US" sz="1000" dirty="0"/>
+          </a:p>
+        </p:txBody>
+      </p:sp>
+      <p:sp>
+        <p:nvSpPr>
+          <p:cNvPr id="19" name="Shape 16"/>
+          <p:cNvSpPr/>
+          <p:nvPr/>
+        </p:nvSpPr>
+        <p:spPr>
+          <a:xfrm>
+            <a:off x="6675120" y="1600200"/>
+            <a:ext cx="1783080" cy="2788920"/>
+          </a:xfrm>
+          <a:prstGeom prst="roundRect">
+            <a:avLst>
+              <a:gd name="adj" fmla="val 5128"/>
+            </a:avLst>
+          </a:prstGeom>
+          <a:solidFill>
+            <a:srgbClr val="0D2118"/>
+          </a:solidFill>
+          <a:ln w="12700">
+            <a:solidFill>
+              <a:srgbClr val="1F3A2B"/>
+            </a:solidFill>
+            <a:prstDash val="dash"/>
+          </a:ln>
+        </p:spPr>
+      </p:sp>
+      <p:sp>
+        <p:nvSpPr>
+          <p:cNvPr id="20" name="Shape 17"/>
+          <p:cNvSpPr/>
+          <p:nvPr/>
+        </p:nvSpPr>
+        <p:spPr>
+          <a:xfrm>
+            <a:off x="7292340" y="2720340"/>
+            <a:ext cx="548640" cy="548640"/>
+          </a:xfrm>
+          <a:prstGeom prst="ellipse">
+            <a:avLst/>
+          </a:prstGeom>
+          <a:solidFill>
+            <a:srgbClr val="07160F"/>
+          </a:solidFill>
+          <a:ln w="19050">
+            <a:solidFill>
+              <a:srgbClr val="35C06F"/>
+            </a:solidFill>
+            <a:prstDash val="solid"/>
+          </a:ln>
+        </p:spPr>
+      </p:sp>
+      <p:sp>
+        <p:nvSpPr>
+          <p:cNvPr id="21" name="Text 18"/>
+          <p:cNvSpPr/>
+          <p:nvPr/>
+        </p:nvSpPr>
+        <p:spPr>
+          <a:xfrm>
+            <a:off x="7292340" y="2720340"/>
+            <a:ext cx="548640" cy="548640"/>
+          </a:xfrm>
+          <a:prstGeom prst="rect">
+            <a:avLst/>
+          </a:prstGeom>
+          <a:noFill/>
+          <a:ln/>
+        </p:spPr>
+        <p:txBody>
+          <a:bodyPr wrap="square" rtlCol="0" anchor="ctr"/>
+          <a:lstStyle/>
+          <a:p>
+            <a:pPr algn="ctr" indent="0" marL="0">
+              <a:buNone/>
+            </a:pPr>
+            <a:r>
+              <a:rPr lang="en-US" sz="1600" dirty="0">
+                <a:solidFill>
+                  <a:srgbClr val="35C06F"/>
+                </a:solidFill>
+                <a:latin typeface="Helvetica" pitchFamily="34" charset="0"/>
+                <a:ea typeface="Helvetica" pitchFamily="34" charset="-122"/>
+                <a:cs typeface="Helvetica" pitchFamily="34" charset="-120"/>
+              </a:rPr>
+              <a:t>▶</a:t>
+            </a:r>
+            <a:endParaRPr lang="en-US" sz="1600" dirty="0"/>
+          </a:p>
+        </p:txBody>
+      </p:sp>
+    </p:spTree>
+  </p:cSld>
+  <p:clrMapOvr>
+    <a:masterClrMapping/>
+  </p:clrMapOvr>
+</p:sld>
+</file>
+
 <file path=ppt/theme/theme1.xml><?xml version="1.0" encoding="utf-8"?>
 <a:theme xmlns:a="http://schemas.openxmlformats.org/drawingml/2006/main" name="Office Theme">
   <a:themeElements>

</xml_diff>